<commit_message>
Business case: kostenpagina pptx met de grafiek als afbeelding
Co-Authored-By: Claude Opus 5.5 <noreply@anthropic.com>
Claude-Session: https://claude.ai/code/session_01N8nwrWExSKGjo2t8Td3eSo
</commit_message>
<xml_diff>
--- a/GTM/Knowledge/business-case/pptx/kosten-bewerkbaar.pptx
+++ b/GTM/Knowledge/business-case/pptx/kosten-bewerkbaar.pptx
@@ -105,593 +105,6 @@
     </a:lvl9pPr>
   </p:defaultTextStyle>
 </p:presentation>
-</file>
-
-<file path=ppt/charts/chart1.xml><?xml version="1.0" encoding="utf-8"?>
-<c:chartSpace xmlns:c="http://schemas.openxmlformats.org/drawingml/2006/chart" xmlns:a="http://schemas.openxmlformats.org/drawingml/2006/main" xmlns:r="http://schemas.openxmlformats.org/officeDocument/2006/relationships">
-  <c:date1904 val="0"/>
-  <c:chart>
-    <c:autoTitleDeleted val="0"/>
-    <c:plotArea>
-      <c:lineChart>
-        <c:grouping val="standard"/>
-        <c:varyColors val="0"/>
-        <c:ser>
-          <c:idx val="0"/>
-          <c:order val="0"/>
-          <c:tx>
-            <c:strRef>
-              <c:f>Sheet1!$B$1</c:f>
-              <c:strCache>
-                <c:ptCount val="1"/>
-                <c:pt idx="0">
-                  <c:v>Nakijken nu</c:v>
-                </c:pt>
-              </c:strCache>
-            </c:strRef>
-          </c:tx>
-          <c:spPr>
-            <a:ln w="31750">
-              <a:solidFill>
-                <a:srgbClr val="9AA3B2"/>
-              </a:solidFill>
-            </a:ln>
-          </c:spPr>
-          <c:marker>
-            <c:symbol val="none"/>
-          </c:marker>
-          <c:dLbls>
-            <c:dLbl>
-              <c:idx val="23"/>
-              <c:tx>
-                <c:rich>
-                  <a:bodyPr/>
-                  <a:lstStyle/>
-                  <a:p>
-                    <a:pPr>
-                      <a:defRPr/>
-                    </a:pPr>
-                    <a:r>
-                      <a:rPr sz="1100" b="1">
-                        <a:solidFill>
-                          <a:srgbClr val="1D2433"/>
-                        </a:solidFill>
-                        <a:latin typeface="Inter"/>
-                      </a:rPr>
-                      <a:t>€ 82.740</a:t>
-                    </a:r>
-                  </a:p>
-                </c:rich>
-              </c:tx>
-              <c:dLblPos val="r"/>
-              <c:showLegendKey val="0"/>
-              <c:showVal val="1"/>
-              <c:showCatName val="0"/>
-              <c:showSerName val="0"/>
-              <c:showPercent val="0"/>
-              <c:showBubbleSize val="0"/>
-            </c:dLbl>
-            <c:showLegendKey val="0"/>
-            <c:showVal val="0"/>
-            <c:showCatName val="0"/>
-            <c:showSerName val="0"/>
-            <c:showPercent val="0"/>
-            <c:showBubbleSize val="0"/>
-            <c:showLeaderLines val="1"/>
-          </c:dLbls>
-          <c:cat>
-            <c:strRef>
-              <c:f>Sheet1!$A$2:$A$25</c:f>
-              <c:strCache>
-                <c:ptCount val="24"/>
-                <c:pt idx="0">
-                  <c:v>mnd 1</c:v>
-                </c:pt>
-                <c:pt idx="1">
-                  <c:v>  </c:v>
-                </c:pt>
-                <c:pt idx="2">
-                  <c:v>   </c:v>
-                </c:pt>
-                <c:pt idx="3">
-                  <c:v>    </c:v>
-                </c:pt>
-                <c:pt idx="4">
-                  <c:v>     </c:v>
-                </c:pt>
-                <c:pt idx="5">
-                  <c:v>mnd 6</c:v>
-                </c:pt>
-                <c:pt idx="6">
-                  <c:v>       </c:v>
-                </c:pt>
-                <c:pt idx="7">
-                  <c:v>        </c:v>
-                </c:pt>
-                <c:pt idx="8">
-                  <c:v>         </c:v>
-                </c:pt>
-                <c:pt idx="9">
-                  <c:v>          </c:v>
-                </c:pt>
-                <c:pt idx="10">
-                  <c:v>           </c:v>
-                </c:pt>
-                <c:pt idx="11">
-                  <c:v>mnd 12</c:v>
-                </c:pt>
-                <c:pt idx="12">
-                  <c:v>             </c:v>
-                </c:pt>
-                <c:pt idx="13">
-                  <c:v>              </c:v>
-                </c:pt>
-                <c:pt idx="14">
-                  <c:v>               </c:v>
-                </c:pt>
-                <c:pt idx="15">
-                  <c:v>                </c:v>
-                </c:pt>
-                <c:pt idx="16">
-                  <c:v>                 </c:v>
-                </c:pt>
-                <c:pt idx="17">
-                  <c:v>mnd 18</c:v>
-                </c:pt>
-                <c:pt idx="18">
-                  <c:v>                   </c:v>
-                </c:pt>
-                <c:pt idx="19">
-                  <c:v>                    </c:v>
-                </c:pt>
-                <c:pt idx="20">
-                  <c:v>                     </c:v>
-                </c:pt>
-                <c:pt idx="21">
-                  <c:v>                      </c:v>
-                </c:pt>
-                <c:pt idx="22">
-                  <c:v>                       </c:v>
-                </c:pt>
-                <c:pt idx="23">
-                  <c:v>mnd 24</c:v>
-                </c:pt>
-              </c:strCache>
-            </c:strRef>
-          </c:cat>
-          <c:val>
-            <c:numRef>
-              <c:f>Sheet1!$B$2:$B$25</c:f>
-              <c:numCache>
-                <c:formatCode>General</c:formatCode>
-                <c:ptCount val="24"/>
-                <c:pt idx="0">
-                  <c:v>3083</c:v>
-                </c:pt>
-                <c:pt idx="1">
-                  <c:v>6166</c:v>
-                </c:pt>
-                <c:pt idx="2">
-                  <c:v>9249</c:v>
-                </c:pt>
-                <c:pt idx="3">
-                  <c:v>12332</c:v>
-                </c:pt>
-                <c:pt idx="4">
-                  <c:v>15415</c:v>
-                </c:pt>
-                <c:pt idx="5">
-                  <c:v>18498</c:v>
-                </c:pt>
-                <c:pt idx="6">
-                  <c:v>21580</c:v>
-                </c:pt>
-                <c:pt idx="7">
-                  <c:v>24663</c:v>
-                </c:pt>
-                <c:pt idx="8">
-                  <c:v>27746</c:v>
-                </c:pt>
-                <c:pt idx="9">
-                  <c:v>30829</c:v>
-                </c:pt>
-                <c:pt idx="10">
-                  <c:v>33912</c:v>
-                </c:pt>
-                <c:pt idx="11">
-                  <c:v>36995</c:v>
-                </c:pt>
-                <c:pt idx="12">
-                  <c:v>40807</c:v>
-                </c:pt>
-                <c:pt idx="13">
-                  <c:v>44619</c:v>
-                </c:pt>
-                <c:pt idx="14">
-                  <c:v>48431</c:v>
-                </c:pt>
-                <c:pt idx="15">
-                  <c:v>52243</c:v>
-                </c:pt>
-                <c:pt idx="16">
-                  <c:v>56055</c:v>
-                </c:pt>
-                <c:pt idx="17">
-                  <c:v>59868</c:v>
-                </c:pt>
-                <c:pt idx="18">
-                  <c:v>63680</c:v>
-                </c:pt>
-                <c:pt idx="19">
-                  <c:v>67492</c:v>
-                </c:pt>
-                <c:pt idx="20">
-                  <c:v>71304</c:v>
-                </c:pt>
-                <c:pt idx="21">
-                  <c:v>75116</c:v>
-                </c:pt>
-                <c:pt idx="22">
-                  <c:v>78928</c:v>
-                </c:pt>
-                <c:pt idx="23">
-                  <c:v>82740</c:v>
-                </c:pt>
-              </c:numCache>
-            </c:numRef>
-          </c:val>
-          <c:smooth val="0"/>
-        </c:ser>
-        <c:ser>
-          <c:idx val="1"/>
-          <c:order val="1"/>
-          <c:tx>
-            <c:strRef>
-              <c:f>Sheet1!$C$1</c:f>
-              <c:strCache>
-                <c:ptCount val="1"/>
-                <c:pt idx="0">
-                  <c:v>Eduface</c:v>
-                </c:pt>
-              </c:strCache>
-            </c:strRef>
-          </c:tx>
-          <c:spPr>
-            <a:ln w="31750">
-              <a:solidFill>
-                <a:srgbClr val="0B1533"/>
-              </a:solidFill>
-            </a:ln>
-          </c:spPr>
-          <c:marker>
-            <c:symbol val="none"/>
-          </c:marker>
-          <c:dLbls>
-            <c:dLbl>
-              <c:idx val="23"/>
-              <c:tx>
-                <c:rich>
-                  <a:bodyPr/>
-                  <a:lstStyle/>
-                  <a:p>
-                    <a:pPr>
-                      <a:defRPr/>
-                    </a:pPr>
-                    <a:r>
-                      <a:rPr sz="1100" b="1">
-                        <a:solidFill>
-                          <a:srgbClr val="1D2433"/>
-                        </a:solidFill>
-                        <a:latin typeface="Inter"/>
-                      </a:rPr>
-                      <a:t>€ 36.000</a:t>
-                    </a:r>
-                  </a:p>
-                </c:rich>
-              </c:tx>
-              <c:dLblPos val="r"/>
-              <c:showLegendKey val="0"/>
-              <c:showVal val="1"/>
-              <c:showCatName val="0"/>
-              <c:showSerName val="0"/>
-              <c:showPercent val="0"/>
-              <c:showBubbleSize val="0"/>
-            </c:dLbl>
-            <c:showLegendKey val="0"/>
-            <c:showVal val="0"/>
-            <c:showCatName val="0"/>
-            <c:showSerName val="0"/>
-            <c:showPercent val="0"/>
-            <c:showBubbleSize val="0"/>
-            <c:showLeaderLines val="1"/>
-          </c:dLbls>
-          <c:cat>
-            <c:strRef>
-              <c:f>Sheet1!$A$2:$A$25</c:f>
-              <c:strCache>
-                <c:ptCount val="24"/>
-                <c:pt idx="0">
-                  <c:v>mnd 1</c:v>
-                </c:pt>
-                <c:pt idx="1">
-                  <c:v>  </c:v>
-                </c:pt>
-                <c:pt idx="2">
-                  <c:v>   </c:v>
-                </c:pt>
-                <c:pt idx="3">
-                  <c:v>    </c:v>
-                </c:pt>
-                <c:pt idx="4">
-                  <c:v>     </c:v>
-                </c:pt>
-                <c:pt idx="5">
-                  <c:v>mnd 6</c:v>
-                </c:pt>
-                <c:pt idx="6">
-                  <c:v>       </c:v>
-                </c:pt>
-                <c:pt idx="7">
-                  <c:v>        </c:v>
-                </c:pt>
-                <c:pt idx="8">
-                  <c:v>         </c:v>
-                </c:pt>
-                <c:pt idx="9">
-                  <c:v>          </c:v>
-                </c:pt>
-                <c:pt idx="10">
-                  <c:v>           </c:v>
-                </c:pt>
-                <c:pt idx="11">
-                  <c:v>mnd 12</c:v>
-                </c:pt>
-                <c:pt idx="12">
-                  <c:v>             </c:v>
-                </c:pt>
-                <c:pt idx="13">
-                  <c:v>              </c:v>
-                </c:pt>
-                <c:pt idx="14">
-                  <c:v>               </c:v>
-                </c:pt>
-                <c:pt idx="15">
-                  <c:v>                </c:v>
-                </c:pt>
-                <c:pt idx="16">
-                  <c:v>                 </c:v>
-                </c:pt>
-                <c:pt idx="17">
-                  <c:v>mnd 18</c:v>
-                </c:pt>
-                <c:pt idx="18">
-                  <c:v>                   </c:v>
-                </c:pt>
-                <c:pt idx="19">
-                  <c:v>                    </c:v>
-                </c:pt>
-                <c:pt idx="20">
-                  <c:v>                     </c:v>
-                </c:pt>
-                <c:pt idx="21">
-                  <c:v>                      </c:v>
-                </c:pt>
-                <c:pt idx="22">
-                  <c:v>                       </c:v>
-                </c:pt>
-                <c:pt idx="23">
-                  <c:v>mnd 24</c:v>
-                </c:pt>
-              </c:strCache>
-            </c:strRef>
-          </c:cat>
-          <c:val>
-            <c:numRef>
-              <c:f>Sheet1!$C$2:$C$25</c:f>
-              <c:numCache>
-                <c:formatCode>General</c:formatCode>
-                <c:ptCount val="24"/>
-                <c:pt idx="0">
-                  <c:v>1500</c:v>
-                </c:pt>
-                <c:pt idx="1">
-                  <c:v>3000</c:v>
-                </c:pt>
-                <c:pt idx="2">
-                  <c:v>4500</c:v>
-                </c:pt>
-                <c:pt idx="3">
-                  <c:v>6000</c:v>
-                </c:pt>
-                <c:pt idx="4">
-                  <c:v>7500</c:v>
-                </c:pt>
-                <c:pt idx="5">
-                  <c:v>9000</c:v>
-                </c:pt>
-                <c:pt idx="6">
-                  <c:v>10500</c:v>
-                </c:pt>
-                <c:pt idx="7">
-                  <c:v>12000</c:v>
-                </c:pt>
-                <c:pt idx="8">
-                  <c:v>13500</c:v>
-                </c:pt>
-                <c:pt idx="9">
-                  <c:v>15000</c:v>
-                </c:pt>
-                <c:pt idx="10">
-                  <c:v>16500</c:v>
-                </c:pt>
-                <c:pt idx="11">
-                  <c:v>18000</c:v>
-                </c:pt>
-                <c:pt idx="12">
-                  <c:v>19500</c:v>
-                </c:pt>
-                <c:pt idx="13">
-                  <c:v>21000</c:v>
-                </c:pt>
-                <c:pt idx="14">
-                  <c:v>22500</c:v>
-                </c:pt>
-                <c:pt idx="15">
-                  <c:v>24000</c:v>
-                </c:pt>
-                <c:pt idx="16">
-                  <c:v>25500</c:v>
-                </c:pt>
-                <c:pt idx="17">
-                  <c:v>27000</c:v>
-                </c:pt>
-                <c:pt idx="18">
-                  <c:v>28500</c:v>
-                </c:pt>
-                <c:pt idx="19">
-                  <c:v>30000</c:v>
-                </c:pt>
-                <c:pt idx="20">
-                  <c:v>31500</c:v>
-                </c:pt>
-                <c:pt idx="21">
-                  <c:v>33000</c:v>
-                </c:pt>
-                <c:pt idx="22">
-                  <c:v>34500</c:v>
-                </c:pt>
-                <c:pt idx="23">
-                  <c:v>36000</c:v>
-                </c:pt>
-              </c:numCache>
-            </c:numRef>
-          </c:val>
-          <c:smooth val="0"/>
-        </c:ser>
-        <c:marker val="1"/>
-        <c:smooth val="0"/>
-        <c:axId val="2118791784"/>
-        <c:axId val="2140495176"/>
-      </c:lineChart>
-      <c:catAx>
-        <c:axId val="2118791784"/>
-        <c:scaling>
-          <c:orientation val="minMax"/>
-        </c:scaling>
-        <c:delete val="0"/>
-        <c:axPos val="b"/>
-        <c:majorTickMark val="out"/>
-        <c:minorTickMark val="none"/>
-        <c:tickLblPos val="nextTo"/>
-        <c:spPr>
-          <a:ln>
-            <a:solidFill>
-              <a:srgbClr val="9AA3B2"/>
-            </a:solidFill>
-          </a:ln>
-        </c:spPr>
-        <c:txPr>
-          <a:bodyPr/>
-          <a:lstStyle/>
-          <a:p>
-            <a:pPr>
-              <a:defRPr sz="1000">
-                <a:solidFill>
-                  <a:srgbClr val="5B6474"/>
-                </a:solidFill>
-              </a:defRPr>
-            </a:pPr>
-          </a:p>
-        </c:txPr>
-        <c:crossAx val="2140495176"/>
-        <c:crosses val="autoZero"/>
-        <c:auto val="1"/>
-        <c:lblAlgn val="ctr"/>
-        <c:lblOffset val="100"/>
-        <c:tickLblSkip val="6"/>
-        <c:noMultiLvlLbl val="0"/>
-      </c:catAx>
-      <c:valAx>
-        <c:axId val="2140495176"/>
-        <c:scaling>
-          <c:max val="90000.0"/>
-          <c:min val="0.0"/>
-        </c:scaling>
-        <c:delete val="0"/>
-        <c:axPos val="l"/>
-        <c:majorGridlines>
-          <c:spPr>
-            <a:ln>
-              <a:solidFill>
-                <a:srgbClr val="ECEEF2"/>
-              </a:solidFill>
-            </a:ln>
-          </c:spPr>
-        </c:majorGridlines>
-        <c:numFmt formatCode="#,##0" sourceLinked="0"/>
-        <c:majorTickMark val="out"/>
-        <c:minorTickMark val="none"/>
-        <c:tickLblPos val="nextTo"/>
-        <c:spPr>
-          <a:ln>
-            <a:noFill/>
-          </a:ln>
-        </c:spPr>
-        <c:txPr>
-          <a:bodyPr/>
-          <a:lstStyle/>
-          <a:p>
-            <a:pPr>
-              <a:defRPr sz="1000">
-                <a:solidFill>
-                  <a:srgbClr val="5B6474"/>
-                </a:solidFill>
-              </a:defRPr>
-            </a:pPr>
-          </a:p>
-        </c:txPr>
-        <c:crossAx val="2118791784"/>
-        <c:crosses val="autoZero"/>
-        <c:majorUnit val="30000.0"/>
-      </c:valAx>
-    </c:plotArea>
-    <c:legend>
-      <c:legendPos val="t"/>
-      <c:layout/>
-      <c:overlay val="0"/>
-      <c:txPr>
-        <a:bodyPr/>
-        <a:lstStyle/>
-        <a:p>
-          <a:pPr>
-            <a:defRPr sz="1100">
-              <a:solidFill>
-                <a:srgbClr val="5B6474"/>
-              </a:solidFill>
-              <a:latin typeface="Inter"/>
-            </a:defRPr>
-          </a:pPr>
-        </a:p>
-      </c:txPr>
-    </c:legend>
-    <c:plotVisOnly val="1"/>
-    <c:dispBlanksAs val="gap"/>
-    <c:showDLblsOverMax val="0"/>
-  </c:chart>
-  <c:txPr>
-    <a:bodyPr/>
-    <a:lstStyle/>
-    <a:p>
-      <a:pPr>
-        <a:defRPr sz="1800"/>
-      </a:pPr>
-      <a:endParaRPr lang="en-US"/>
-    </a:p>
-  </c:txPr>
-  <c:externalData r:id="rId1">
-    <c:autoUpdate val="0"/>
-  </c:externalData>
-</c:chartSpace>
 </file>
 
 <file path=ppt/slideLayouts/slideLayout1.xml><?xml version="1.0" encoding="utf-8"?>
@@ -3982,61 +3395,33 @@
           </a:p>
         </p:txBody>
       </p:sp>
-      <p:sp>
-        <p:nvSpPr>
-          <p:cNvPr id="10" name="TextBox 9"/>
-          <p:cNvSpPr txBox="1"/>
+      <p:pic>
+        <p:nvPicPr>
+          <p:cNvPr id="10" name="Picture 9" descr="kosten-grafiek.png"/>
+          <p:cNvPicPr>
+            <a:picLocks noChangeAspect="1"/>
+          </p:cNvPicPr>
           <p:nvPr/>
-        </p:nvSpPr>
+        </p:nvPicPr>
+        <p:blipFill>
+          <a:blip r:embed="rId2"/>
+          <a:stretch>
+            <a:fillRect/>
+          </a:stretch>
+        </p:blipFill>
         <p:spPr>
           <a:xfrm>
-            <a:off x="762000" y="2362200"/>
-            <a:ext cx="10668000" cy="190500"/>
+            <a:off x="762000" y="2387600"/>
+            <a:ext cx="9180723" cy="3048000"/>
           </a:xfrm>
           <a:prstGeom prst="rect">
             <a:avLst/>
           </a:prstGeom>
-          <a:noFill/>
         </p:spPr>
-        <p:txBody>
-          <a:bodyPr wrap="square" anchor="t" lIns="0" rIns="0" tIns="0" bIns="0">
-            <a:spAutoFit/>
-          </a:bodyPr>
-          <a:lstStyle/>
-          <a:p>
-            <a:r>
-              <a:rPr sz="1300" b="1">
-                <a:solidFill>
-                  <a:srgbClr val="1D2433"/>
-                </a:solidFill>
-                <a:latin typeface="Inter"/>
-              </a:rPr>
-              <a:t>Opgeteld na twee jaar: nakijken nu € 82.740, Eduface € 36.000. Verschil € 46.740.</a:t>
-            </a:r>
-          </a:p>
-        </p:txBody>
-      </p:sp>
-      <p:graphicFrame>
-        <p:nvGraphicFramePr>
-          <p:cNvPr id="11" name="Chart 10"/>
-          <p:cNvGraphicFramePr>
-            <a:graphicFrameLocks noGrp="1"/>
-          </p:cNvGraphicFramePr>
-          <p:nvPr/>
-        </p:nvGraphicFramePr>
-        <p:xfrm>
-          <a:off x="698500" y="2603500"/>
-          <a:ext cx="10731500" cy="2794000"/>
-        </p:xfrm>
-        <a:graphic>
-          <a:graphicData uri="http://schemas.openxmlformats.org/drawingml/2006/chart">
-            <c:chart xmlns:c="http://schemas.openxmlformats.org/drawingml/2006/chart" r:id="rId2"/>
-          </a:graphicData>
-        </a:graphic>
-      </p:graphicFrame>
-      <p:sp>
-        <p:nvSpPr>
-          <p:cNvPr id="12" name="Rectangle 11"/>
+      </p:pic>
+      <p:sp>
+        <p:nvSpPr>
+          <p:cNvPr id="11" name="Rectangle 10"/>
           <p:cNvSpPr/>
           <p:nvPr/>
         </p:nvSpPr>
@@ -4080,7 +3465,7 @@
       </p:sp>
       <p:sp>
         <p:nvSpPr>
-          <p:cNvPr id="13" name="Rectangle 12"/>
+          <p:cNvPr id="12" name="Rectangle 11"/>
           <p:cNvSpPr/>
           <p:nvPr/>
         </p:nvSpPr>
@@ -4124,7 +3509,7 @@
       </p:sp>
       <p:sp>
         <p:nvSpPr>
-          <p:cNvPr id="14" name="TextBox 13"/>
+          <p:cNvPr id="13" name="TextBox 12"/>
           <p:cNvSpPr txBox="1"/>
           <p:nvPr/>
         </p:nvSpPr>
@@ -4169,7 +3554,7 @@
       </p:sp>
       <p:sp>
         <p:nvSpPr>
-          <p:cNvPr id="15" name="TextBox 14"/>
+          <p:cNvPr id="14" name="TextBox 13"/>
           <p:cNvSpPr txBox="1"/>
           <p:nvPr/>
         </p:nvSpPr>

</xml_diff>